<commit_message>
Improve WPS reference recreation fidelity
</commit_message>
<xml_diff>
--- a/experiments/wps-drawing-addon/assets/reference-recreation-base.pptx
+++ b/experiments/wps-drawing-addon/assets/reference-recreation-base.pptx
@@ -2,13 +2,13 @@
 <file path=ppt/presentation.xml><?xml version="1.0" encoding="utf-8"?>
 <p:presentation xmlns:p="http://schemas.openxmlformats.org/presentationml/2006/main">
   <p:sldMasterIdLst>
-    <p:sldMasterId xmlns:r="http://schemas.openxmlformats.org/officeDocument/2006/relationships" id="2147483648" r:id="R0a523fb5a2c9413a"/>
+    <p:sldMasterId xmlns:r="http://schemas.openxmlformats.org/officeDocument/2006/relationships" id="2147483648" r:id="Ra9035a3473c1433c"/>
   </p:sldMasterIdLst>
   <p:notesMasterIdLst>
-    <p:notesMasterId xmlns:r="http://schemas.openxmlformats.org/officeDocument/2006/relationships" r:id="Rf59d402cb509469f"/>
+    <p:notesMasterId xmlns:r="http://schemas.openxmlformats.org/officeDocument/2006/relationships" r:id="Rd586896b50ad4fc7"/>
   </p:notesMasterIdLst>
   <p:sldIdLst>
-    <p:sldId xmlns:r="http://schemas.openxmlformats.org/officeDocument/2006/relationships" id="256" r:id="R91861e2056e242be"/>
+    <p:sldId xmlns:r="http://schemas.openxmlformats.org/officeDocument/2006/relationships" id="256" r:id="Ra0b2ee8cc8ad4257"/>
   </p:sldIdLst>
   <p:sldSz cx="12192000" cy="6858000"/>
   <p:notesSz cx="6858000" cy="9144000"/>
@@ -506,7 +506,7 @@
   </p:cSld>
   <p:clrMap bg1="lt1" tx1="dk1" bg2="lt2" tx2="dk2" accent1="accent1" accent2="accent2" accent3="accent3" accent4="accent4" accent5="accent5" accent6="accent6" hlink="hlink" folHlink="folHlink"/>
   <p:sldLayoutIdLst>
-    <p:sldLayoutId xmlns:r="http://schemas.openxmlformats.org/officeDocument/2006/relationships" id="2147483649" r:id="Rb1f77579f0d9479c"/>
+    <p:sldLayoutId xmlns:r="http://schemas.openxmlformats.org/officeDocument/2006/relationships" id="2147483649" r:id="R75b3e7369f1c4e6c"/>
   </p:sldLayoutIdLst>
   <p:txStyles>
     <p:titleStyle>
@@ -1054,23 +1054,23 @@
       </p:grpSpPr>
       <p:pic>
         <p:nvPicPr>
-          <p:cNvPr id="3" name=""/>
+          <p:cNvPr id="19" name=""/>
           <p:cNvPicPr>
             <a:picLocks xmlns:a="http://schemas.openxmlformats.org/drawingml/2006/main" noChangeAspect="1"/>
           </p:cNvPicPr>
           <p:nvPr/>
         </p:nvPicPr>
         <p:blipFill>
-          <a:blip xmlns:r="http://schemas.openxmlformats.org/officeDocument/2006/relationships" xmlns:a="http://schemas.openxmlformats.org/drawingml/2006/main" r:embed="R994b48b953ef4dc3"/>
-          <a:srcRect xmlns:a="http://schemas.openxmlformats.org/drawingml/2006/main" l="0" t="423" r="0" b="423"/>
+          <a:blip xmlns:r="http://schemas.openxmlformats.org/officeDocument/2006/relationships" xmlns:a="http://schemas.openxmlformats.org/drawingml/2006/main" r:embed="R4acaf736f7ec404a"/>
+          <a:srcRect xmlns:a="http://schemas.openxmlformats.org/drawingml/2006/main" l="1017" t="0" r="1017" b="0"/>
           <a:stretch xmlns:a="http://schemas.openxmlformats.org/drawingml/2006/main">
             <a:fillRect l="0" t="0" r="0" b="0"/>
           </a:stretch>
         </p:blipFill>
         <p:spPr>
           <a:xfrm xmlns:a="http://schemas.openxmlformats.org/drawingml/2006/main">
-            <a:off x="2045018" y="3543300"/>
-            <a:ext cx="1536383" cy="1092518"/>
+            <a:off x="2035915" y="3532909"/>
+            <a:ext cx="1550428" cy="1135007"/>
           </a:xfrm>
           <a:prstGeom xmlns:a="http://schemas.openxmlformats.org/drawingml/2006/main" prst="rect">
             <a:avLst/>
@@ -1079,23 +1079,423 @@
       </p:pic>
       <p:pic>
         <p:nvPicPr>
-          <p:cNvPr id="4" name=""/>
+          <p:cNvPr id="20" name=""/>
           <p:cNvPicPr>
             <a:picLocks xmlns:a="http://schemas.openxmlformats.org/drawingml/2006/main" noChangeAspect="1"/>
           </p:cNvPicPr>
           <p:nvPr/>
         </p:nvPicPr>
         <p:blipFill>
-          <a:blip xmlns:r="http://schemas.openxmlformats.org/officeDocument/2006/relationships" xmlns:a="http://schemas.openxmlformats.org/drawingml/2006/main" r:embed="R8491e5ddc00a41d4"/>
-          <a:srcRect xmlns:a="http://schemas.openxmlformats.org/drawingml/2006/main" l="151" t="0" r="151" b="0"/>
+          <a:blip xmlns:r="http://schemas.openxmlformats.org/officeDocument/2006/relationships" xmlns:a="http://schemas.openxmlformats.org/drawingml/2006/main" r:embed="Ra9955070d7874852"/>
+          <a:srcRect xmlns:a="http://schemas.openxmlformats.org/drawingml/2006/main" l="1017" t="0" r="1017" b="0"/>
           <a:stretch xmlns:a="http://schemas.openxmlformats.org/drawingml/2006/main">
             <a:fillRect l="0" t="0" r="0" b="0"/>
           </a:stretch>
         </p:blipFill>
         <p:spPr>
           <a:xfrm xmlns:a="http://schemas.openxmlformats.org/drawingml/2006/main">
-            <a:off x="5765483" y="3543300"/>
-            <a:ext cx="1587818" cy="1092518"/>
+            <a:off x="5739715" y="3532909"/>
+            <a:ext cx="1620902" cy="1135007"/>
+          </a:xfrm>
+          <a:prstGeom xmlns:a="http://schemas.openxmlformats.org/drawingml/2006/main" prst="rect">
+            <a:avLst/>
+          </a:prstGeom>
+        </p:spPr>
+      </p:pic>
+      <p:pic>
+        <p:nvPicPr>
+          <p:cNvPr id="21" name=""/>
+          <p:cNvPicPr>
+            <a:picLocks xmlns:a="http://schemas.openxmlformats.org/drawingml/2006/main" noChangeAspect="1"/>
+          </p:cNvPicPr>
+          <p:nvPr/>
+        </p:nvPicPr>
+        <p:blipFill>
+          <a:blip xmlns:r="http://schemas.openxmlformats.org/officeDocument/2006/relationships" xmlns:a="http://schemas.openxmlformats.org/drawingml/2006/main" r:embed="R285b17721bec47a4"/>
+          <a:srcRect xmlns:a="http://schemas.openxmlformats.org/drawingml/2006/main" l="1017" t="0" r="1017" b="0"/>
+          <a:stretch xmlns:a="http://schemas.openxmlformats.org/drawingml/2006/main">
+            <a:fillRect l="0" t="0" r="0" b="0"/>
+          </a:stretch>
+        </p:blipFill>
+        <p:spPr>
+          <a:xfrm xmlns:a="http://schemas.openxmlformats.org/drawingml/2006/main">
+            <a:off x="1393819" y="759336"/>
+            <a:ext cx="861349" cy="935182"/>
+          </a:xfrm>
+          <a:prstGeom xmlns:a="http://schemas.openxmlformats.org/drawingml/2006/main" prst="rect">
+            <a:avLst/>
+          </a:prstGeom>
+        </p:spPr>
+      </p:pic>
+      <p:pic>
+        <p:nvPicPr>
+          <p:cNvPr id="22" name=""/>
+          <p:cNvPicPr>
+            <a:picLocks xmlns:a="http://schemas.openxmlformats.org/drawingml/2006/main" noChangeAspect="1"/>
+          </p:cNvPicPr>
+          <p:nvPr/>
+        </p:nvPicPr>
+        <p:blipFill>
+          <a:blip xmlns:r="http://schemas.openxmlformats.org/officeDocument/2006/relationships" xmlns:a="http://schemas.openxmlformats.org/drawingml/2006/main" r:embed="Rdfc04a23336543df"/>
+          <a:srcRect xmlns:a="http://schemas.openxmlformats.org/drawingml/2006/main" l="1017" t="0" r="1017" b="0"/>
+          <a:stretch xmlns:a="http://schemas.openxmlformats.org/drawingml/2006/main">
+            <a:fillRect l="0" t="0" r="0" b="0"/>
+          </a:stretch>
+        </p:blipFill>
+        <p:spPr>
+          <a:xfrm xmlns:a="http://schemas.openxmlformats.org/drawingml/2006/main">
+            <a:off x="3108686" y="2206070"/>
+            <a:ext cx="399353" cy="439615"/>
+          </a:xfrm>
+          <a:prstGeom xmlns:a="http://schemas.openxmlformats.org/drawingml/2006/main" prst="rect">
+            <a:avLst/>
+          </a:prstGeom>
+        </p:spPr>
+      </p:pic>
+      <p:pic>
+        <p:nvPicPr>
+          <p:cNvPr id="23" name=""/>
+          <p:cNvPicPr>
+            <a:picLocks xmlns:a="http://schemas.openxmlformats.org/drawingml/2006/main" noChangeAspect="1"/>
+          </p:cNvPicPr>
+          <p:nvPr/>
+        </p:nvPicPr>
+        <p:blipFill>
+          <a:blip xmlns:r="http://schemas.openxmlformats.org/officeDocument/2006/relationships" xmlns:a="http://schemas.openxmlformats.org/drawingml/2006/main" r:embed="Rfdf032b5ebce429e"/>
+          <a:srcRect xmlns:a="http://schemas.openxmlformats.org/drawingml/2006/main" l="1017" t="0" r="1017" b="0"/>
+          <a:stretch xmlns:a="http://schemas.openxmlformats.org/drawingml/2006/main">
+            <a:fillRect l="0" t="0" r="0" b="0"/>
+          </a:stretch>
+        </p:blipFill>
+        <p:spPr>
+          <a:xfrm xmlns:a="http://schemas.openxmlformats.org/drawingml/2006/main">
+            <a:off x="6914281" y="2206070"/>
+            <a:ext cx="399353" cy="439615"/>
+          </a:xfrm>
+          <a:prstGeom xmlns:a="http://schemas.openxmlformats.org/drawingml/2006/main" prst="rect">
+            <a:avLst/>
+          </a:prstGeom>
+        </p:spPr>
+      </p:pic>
+      <p:pic>
+        <p:nvPicPr>
+          <p:cNvPr id="24" name=""/>
+          <p:cNvPicPr>
+            <a:picLocks xmlns:a="http://schemas.openxmlformats.org/drawingml/2006/main" noChangeAspect="1"/>
+          </p:cNvPicPr>
+          <p:nvPr/>
+        </p:nvPicPr>
+        <p:blipFill>
+          <a:blip xmlns:r="http://schemas.openxmlformats.org/officeDocument/2006/relationships" xmlns:a="http://schemas.openxmlformats.org/drawingml/2006/main" r:embed="R70c58e1276a84e38"/>
+          <a:srcRect xmlns:a="http://schemas.openxmlformats.org/drawingml/2006/main" l="1017" t="0" r="1017" b="0"/>
+          <a:stretch xmlns:a="http://schemas.openxmlformats.org/drawingml/2006/main">
+            <a:fillRect l="0" t="0" r="0" b="0"/>
+          </a:stretch>
+        </p:blipFill>
+        <p:spPr>
+          <a:xfrm xmlns:a="http://schemas.openxmlformats.org/drawingml/2006/main">
+            <a:off x="156609" y="3013364"/>
+            <a:ext cx="391522" cy="447608"/>
+          </a:xfrm>
+          <a:prstGeom xmlns:a="http://schemas.openxmlformats.org/drawingml/2006/main" prst="rect">
+            <a:avLst/>
+          </a:prstGeom>
+        </p:spPr>
+      </p:pic>
+      <p:pic>
+        <p:nvPicPr>
+          <p:cNvPr id="25" name=""/>
+          <p:cNvPicPr>
+            <a:picLocks xmlns:a="http://schemas.openxmlformats.org/drawingml/2006/main" noChangeAspect="1"/>
+          </p:cNvPicPr>
+          <p:nvPr/>
+        </p:nvPicPr>
+        <p:blipFill>
+          <a:blip xmlns:r="http://schemas.openxmlformats.org/officeDocument/2006/relationships" xmlns:a="http://schemas.openxmlformats.org/drawingml/2006/main" r:embed="Raf5a932b97bd4798"/>
+          <a:srcRect xmlns:a="http://schemas.openxmlformats.org/drawingml/2006/main" l="1017" t="0" r="1017" b="0"/>
+          <a:stretch xmlns:a="http://schemas.openxmlformats.org/drawingml/2006/main">
+            <a:fillRect l="0" t="0" r="0" b="0"/>
+          </a:stretch>
+        </p:blipFill>
+        <p:spPr>
+          <a:xfrm xmlns:a="http://schemas.openxmlformats.org/drawingml/2006/main">
+            <a:off x="3899561" y="3013364"/>
+            <a:ext cx="391522" cy="447608"/>
+          </a:xfrm>
+          <a:prstGeom xmlns:a="http://schemas.openxmlformats.org/drawingml/2006/main" prst="rect">
+            <a:avLst/>
+          </a:prstGeom>
+        </p:spPr>
+      </p:pic>
+      <p:pic>
+        <p:nvPicPr>
+          <p:cNvPr id="26" name=""/>
+          <p:cNvPicPr>
+            <a:picLocks xmlns:a="http://schemas.openxmlformats.org/drawingml/2006/main" noChangeAspect="1"/>
+          </p:cNvPicPr>
+          <p:nvPr/>
+        </p:nvPicPr>
+        <p:blipFill>
+          <a:blip xmlns:r="http://schemas.openxmlformats.org/officeDocument/2006/relationships" xmlns:a="http://schemas.openxmlformats.org/drawingml/2006/main" r:embed="Rfba4c838cf964616"/>
+          <a:srcRect xmlns:a="http://schemas.openxmlformats.org/drawingml/2006/main" l="1017" t="0" r="1017" b="0"/>
+          <a:stretch xmlns:a="http://schemas.openxmlformats.org/drawingml/2006/main">
+            <a:fillRect l="0" t="0" r="0" b="0"/>
+          </a:stretch>
+        </p:blipFill>
+        <p:spPr>
+          <a:xfrm xmlns:a="http://schemas.openxmlformats.org/drawingml/2006/main">
+            <a:off x="101796" y="2102161"/>
+            <a:ext cx="321048" cy="383664"/>
+          </a:xfrm>
+          <a:prstGeom xmlns:a="http://schemas.openxmlformats.org/drawingml/2006/main" prst="rect">
+            <a:avLst/>
+          </a:prstGeom>
+        </p:spPr>
+      </p:pic>
+      <p:pic>
+        <p:nvPicPr>
+          <p:cNvPr id="27" name=""/>
+          <p:cNvPicPr>
+            <a:picLocks xmlns:a="http://schemas.openxmlformats.org/drawingml/2006/main" noChangeAspect="1"/>
+          </p:cNvPicPr>
+          <p:nvPr/>
+        </p:nvPicPr>
+        <p:blipFill>
+          <a:blip xmlns:r="http://schemas.openxmlformats.org/officeDocument/2006/relationships" xmlns:a="http://schemas.openxmlformats.org/drawingml/2006/main" r:embed="R0a19b23b536b40e1"/>
+          <a:srcRect xmlns:a="http://schemas.openxmlformats.org/drawingml/2006/main" l="1017" t="0" r="1017" b="0"/>
+          <a:stretch xmlns:a="http://schemas.openxmlformats.org/drawingml/2006/main">
+            <a:fillRect l="0" t="0" r="0" b="0"/>
+          </a:stretch>
+        </p:blipFill>
+        <p:spPr>
+          <a:xfrm xmlns:a="http://schemas.openxmlformats.org/drawingml/2006/main">
+            <a:off x="3860408" y="2102161"/>
+            <a:ext cx="321048" cy="383664"/>
+          </a:xfrm>
+          <a:prstGeom xmlns:a="http://schemas.openxmlformats.org/drawingml/2006/main" prst="rect">
+            <a:avLst/>
+          </a:prstGeom>
+        </p:spPr>
+      </p:pic>
+      <p:pic>
+        <p:nvPicPr>
+          <p:cNvPr id="28" name=""/>
+          <p:cNvPicPr>
+            <a:picLocks xmlns:a="http://schemas.openxmlformats.org/drawingml/2006/main" noChangeAspect="1"/>
+          </p:cNvPicPr>
+          <p:nvPr/>
+        </p:nvPicPr>
+        <p:blipFill>
+          <a:blip xmlns:r="http://schemas.openxmlformats.org/officeDocument/2006/relationships" xmlns:a="http://schemas.openxmlformats.org/drawingml/2006/main" r:embed="R98f3c6fa05414854"/>
+          <a:srcRect xmlns:a="http://schemas.openxmlformats.org/drawingml/2006/main" l="1017" t="0" r="1017" b="0"/>
+          <a:stretch xmlns:a="http://schemas.openxmlformats.org/drawingml/2006/main">
+            <a:fillRect l="0" t="0" r="0" b="0"/>
+          </a:stretch>
+        </p:blipFill>
+        <p:spPr>
+          <a:xfrm xmlns:a="http://schemas.openxmlformats.org/drawingml/2006/main">
+            <a:off x="1973272" y="3013364"/>
+            <a:ext cx="328879" cy="367678"/>
+          </a:xfrm>
+          <a:prstGeom xmlns:a="http://schemas.openxmlformats.org/drawingml/2006/main" prst="rect">
+            <a:avLst/>
+          </a:prstGeom>
+        </p:spPr>
+      </p:pic>
+      <p:pic>
+        <p:nvPicPr>
+          <p:cNvPr id="29" name=""/>
+          <p:cNvPicPr>
+            <a:picLocks xmlns:a="http://schemas.openxmlformats.org/drawingml/2006/main" noChangeAspect="1"/>
+          </p:cNvPicPr>
+          <p:nvPr/>
+        </p:nvPicPr>
+        <p:blipFill>
+          <a:blip xmlns:r="http://schemas.openxmlformats.org/officeDocument/2006/relationships" xmlns:a="http://schemas.openxmlformats.org/drawingml/2006/main" r:embed="R46cfa6f4527b4754"/>
+          <a:srcRect xmlns:a="http://schemas.openxmlformats.org/drawingml/2006/main" l="1017" t="0" r="1017" b="0"/>
+          <a:stretch xmlns:a="http://schemas.openxmlformats.org/drawingml/2006/main">
+            <a:fillRect l="0" t="0" r="0" b="0"/>
+          </a:stretch>
+        </p:blipFill>
+        <p:spPr>
+          <a:xfrm xmlns:a="http://schemas.openxmlformats.org/drawingml/2006/main">
+            <a:off x="5645750" y="2989385"/>
+            <a:ext cx="336709" cy="351692"/>
+          </a:xfrm>
+          <a:prstGeom xmlns:a="http://schemas.openxmlformats.org/drawingml/2006/main" prst="rect">
+            <a:avLst/>
+          </a:prstGeom>
+        </p:spPr>
+      </p:pic>
+      <p:pic>
+        <p:nvPicPr>
+          <p:cNvPr id="30" name=""/>
+          <p:cNvPicPr>
+            <a:picLocks xmlns:a="http://schemas.openxmlformats.org/drawingml/2006/main" noChangeAspect="1"/>
+          </p:cNvPicPr>
+          <p:nvPr/>
+        </p:nvPicPr>
+        <p:blipFill>
+          <a:blip xmlns:r="http://schemas.openxmlformats.org/officeDocument/2006/relationships" xmlns:a="http://schemas.openxmlformats.org/drawingml/2006/main" r:embed="R7599267e7bc04f74"/>
+          <a:srcRect xmlns:a="http://schemas.openxmlformats.org/drawingml/2006/main" l="1017" t="0" r="1017" b="0"/>
+          <a:stretch xmlns:a="http://schemas.openxmlformats.org/drawingml/2006/main">
+            <a:fillRect l="0" t="0" r="0" b="0"/>
+          </a:stretch>
+        </p:blipFill>
+        <p:spPr>
+          <a:xfrm xmlns:a="http://schemas.openxmlformats.org/drawingml/2006/main">
+            <a:off x="7423260" y="383664"/>
+            <a:ext cx="391522" cy="399650"/>
+          </a:xfrm>
+          <a:prstGeom xmlns:a="http://schemas.openxmlformats.org/drawingml/2006/main" prst="rect">
+            <a:avLst/>
+          </a:prstGeom>
+        </p:spPr>
+      </p:pic>
+      <p:pic>
+        <p:nvPicPr>
+          <p:cNvPr id="31" name=""/>
+          <p:cNvPicPr>
+            <a:picLocks xmlns:a="http://schemas.openxmlformats.org/drawingml/2006/main" noChangeAspect="1"/>
+          </p:cNvPicPr>
+          <p:nvPr/>
+        </p:nvPicPr>
+        <p:blipFill>
+          <a:blip xmlns:r="http://schemas.openxmlformats.org/officeDocument/2006/relationships" xmlns:a="http://schemas.openxmlformats.org/drawingml/2006/main" r:embed="R317fd558ba994dc6"/>
+          <a:srcRect xmlns:a="http://schemas.openxmlformats.org/drawingml/2006/main" l="1017" t="0" r="1017" b="0"/>
+          <a:stretch xmlns:a="http://schemas.openxmlformats.org/drawingml/2006/main">
+            <a:fillRect l="0" t="0" r="0" b="0"/>
+          </a:stretch>
+        </p:blipFill>
+        <p:spPr>
+          <a:xfrm xmlns:a="http://schemas.openxmlformats.org/drawingml/2006/main">
+            <a:off x="7431091" y="2797552"/>
+            <a:ext cx="391522" cy="399650"/>
+          </a:xfrm>
+          <a:prstGeom xmlns:a="http://schemas.openxmlformats.org/drawingml/2006/main" prst="rect">
+            <a:avLst/>
+          </a:prstGeom>
+        </p:spPr>
+      </p:pic>
+      <p:pic>
+        <p:nvPicPr>
+          <p:cNvPr id="32" name=""/>
+          <p:cNvPicPr>
+            <a:picLocks xmlns:a="http://schemas.openxmlformats.org/drawingml/2006/main" noChangeAspect="1"/>
+          </p:cNvPicPr>
+          <p:nvPr/>
+        </p:nvPicPr>
+        <p:blipFill>
+          <a:blip xmlns:r="http://schemas.openxmlformats.org/officeDocument/2006/relationships" xmlns:a="http://schemas.openxmlformats.org/drawingml/2006/main" r:embed="R725395b5d4b94740"/>
+          <a:srcRect xmlns:a="http://schemas.openxmlformats.org/drawingml/2006/main" l="1017" t="0" r="1017" b="0"/>
+          <a:stretch xmlns:a="http://schemas.openxmlformats.org/drawingml/2006/main">
+            <a:fillRect l="0" t="0" r="0" b="0"/>
+          </a:stretch>
+        </p:blipFill>
+        <p:spPr>
+          <a:xfrm xmlns:a="http://schemas.openxmlformats.org/drawingml/2006/main">
+            <a:off x="657757" y="6074685"/>
+            <a:ext cx="649927" cy="527538"/>
+          </a:xfrm>
+          <a:prstGeom xmlns:a="http://schemas.openxmlformats.org/drawingml/2006/main" prst="rect">
+            <a:avLst/>
+          </a:prstGeom>
+        </p:spPr>
+      </p:pic>
+      <p:pic>
+        <p:nvPicPr>
+          <p:cNvPr id="33" name=""/>
+          <p:cNvPicPr>
+            <a:picLocks xmlns:a="http://schemas.openxmlformats.org/drawingml/2006/main" noChangeAspect="1"/>
+          </p:cNvPicPr>
+          <p:nvPr/>
+        </p:nvPicPr>
+        <p:blipFill>
+          <a:blip xmlns:r="http://schemas.openxmlformats.org/officeDocument/2006/relationships" xmlns:a="http://schemas.openxmlformats.org/drawingml/2006/main" r:embed="R3ff6193644874843"/>
+          <a:srcRect xmlns:a="http://schemas.openxmlformats.org/drawingml/2006/main" l="1017" t="0" r="1017" b="0"/>
+          <a:stretch xmlns:a="http://schemas.openxmlformats.org/drawingml/2006/main">
+            <a:fillRect l="0" t="0" r="0" b="0"/>
+          </a:stretch>
+        </p:blipFill>
+        <p:spPr>
+          <a:xfrm xmlns:a="http://schemas.openxmlformats.org/drawingml/2006/main">
+            <a:off x="3241803" y="6074685"/>
+            <a:ext cx="649927" cy="527538"/>
+          </a:xfrm>
+          <a:prstGeom xmlns:a="http://schemas.openxmlformats.org/drawingml/2006/main" prst="rect">
+            <a:avLst/>
+          </a:prstGeom>
+        </p:spPr>
+      </p:pic>
+      <p:pic>
+        <p:nvPicPr>
+          <p:cNvPr id="34" name=""/>
+          <p:cNvPicPr>
+            <a:picLocks xmlns:a="http://schemas.openxmlformats.org/drawingml/2006/main" noChangeAspect="1"/>
+          </p:cNvPicPr>
+          <p:nvPr/>
+        </p:nvPicPr>
+        <p:blipFill>
+          <a:blip xmlns:r="http://schemas.openxmlformats.org/officeDocument/2006/relationships" xmlns:a="http://schemas.openxmlformats.org/drawingml/2006/main" r:embed="R6402a73470904319"/>
+          <a:srcRect xmlns:a="http://schemas.openxmlformats.org/drawingml/2006/main" l="1017" t="0" r="1017" b="0"/>
+          <a:stretch xmlns:a="http://schemas.openxmlformats.org/drawingml/2006/main">
+            <a:fillRect l="0" t="0" r="0" b="0"/>
+          </a:stretch>
+        </p:blipFill>
+        <p:spPr>
+          <a:xfrm xmlns:a="http://schemas.openxmlformats.org/drawingml/2006/main">
+            <a:off x="9380871" y="5243413"/>
+            <a:ext cx="571622" cy="471587"/>
+          </a:xfrm>
+          <a:prstGeom xmlns:a="http://schemas.openxmlformats.org/drawingml/2006/main" prst="rect">
+            <a:avLst/>
+          </a:prstGeom>
+        </p:spPr>
+      </p:pic>
+      <p:pic>
+        <p:nvPicPr>
+          <p:cNvPr id="35" name=""/>
+          <p:cNvPicPr>
+            <a:picLocks xmlns:a="http://schemas.openxmlformats.org/drawingml/2006/main" noChangeAspect="1"/>
+          </p:cNvPicPr>
+          <p:nvPr/>
+        </p:nvPicPr>
+        <p:blipFill>
+          <a:blip xmlns:r="http://schemas.openxmlformats.org/officeDocument/2006/relationships" xmlns:a="http://schemas.openxmlformats.org/drawingml/2006/main" r:embed="Rf16e79af62404fee"/>
+          <a:srcRect xmlns:a="http://schemas.openxmlformats.org/drawingml/2006/main" l="1017" t="0" r="1017" b="0"/>
+          <a:stretch xmlns:a="http://schemas.openxmlformats.org/drawingml/2006/main">
+            <a:fillRect l="0" t="0" r="0" b="0"/>
+          </a:stretch>
+        </p:blipFill>
+        <p:spPr>
+          <a:xfrm xmlns:a="http://schemas.openxmlformats.org/drawingml/2006/main">
+            <a:off x="9435684" y="5794930"/>
+            <a:ext cx="508979" cy="671413"/>
+          </a:xfrm>
+          <a:prstGeom xmlns:a="http://schemas.openxmlformats.org/drawingml/2006/main" prst="rect">
+            <a:avLst/>
+          </a:prstGeom>
+        </p:spPr>
+      </p:pic>
+      <p:pic>
+        <p:nvPicPr>
+          <p:cNvPr id="36" name=""/>
+          <p:cNvPicPr>
+            <a:picLocks xmlns:a="http://schemas.openxmlformats.org/drawingml/2006/main" noChangeAspect="1"/>
+          </p:cNvPicPr>
+          <p:nvPr/>
+        </p:nvPicPr>
+        <p:blipFill>
+          <a:blip xmlns:r="http://schemas.openxmlformats.org/officeDocument/2006/relationships" xmlns:a="http://schemas.openxmlformats.org/drawingml/2006/main" r:embed="R008a59b6e28547af"/>
+          <a:srcRect xmlns:a="http://schemas.openxmlformats.org/drawingml/2006/main" l="1017" t="0" r="1017" b="0"/>
+          <a:stretch xmlns:a="http://schemas.openxmlformats.org/drawingml/2006/main">
+            <a:fillRect l="0" t="0" r="0" b="0"/>
+          </a:stretch>
+        </p:blipFill>
+        <p:spPr>
+          <a:xfrm xmlns:a="http://schemas.openxmlformats.org/drawingml/2006/main">
+            <a:off x="10492794" y="5387287"/>
+            <a:ext cx="219252" cy="271762"/>
           </a:xfrm>
           <a:prstGeom xmlns:a="http://schemas.openxmlformats.org/drawingml/2006/main" prst="rect">
             <a:avLst/>
@@ -1105,7 +1505,7 @@
     </p:spTree>
     <p:extLst>
       <p:ext uri="{BB962C8B-B14F-4D97-AF65-F5344CB8AC3E}">
-        <p14:creationId xmlns:p14="http://schemas.microsoft.com/office/powerpoint/2010/main" val="2014790256"/>
+        <p14:creationId xmlns:p14="http://schemas.microsoft.com/office/powerpoint/2010/main" val="1920738552"/>
       </p:ext>
     </p:extLst>
   </p:cSld>

</xml_diff>